<commit_message>
모델카드,README.docx 파일 생성 , 21,22,16,2 문서 수정
</commit_message>
<xml_diff>
--- a/document/21_발표자료.pptx
+++ b/document/21_발표자료.pptx
@@ -1,24 +1,25 @@
 
 <file path=ppt/presentation.xml><?xml version="1.0" encoding="utf-8"?>
-<p:presentation xmlns:a="http://schemas.openxmlformats.org/drawingml/2006/main" xmlns:r="http://schemas.openxmlformats.org/officeDocument/2006/relationships" xmlns:p="http://schemas.openxmlformats.org/presentationml/2006/main" saveSubsetFonts="1" autoCompressPictures="0">
+<p:presentation xmlns:a="http://schemas.openxmlformats.org/drawingml/2006/main" xmlns:r="http://schemas.openxmlformats.org/officeDocument/2006/relationships" xmlns:p="http://schemas.openxmlformats.org/presentationml/2006/main" xmlns:p14="http://schemas.microsoft.com/office/powerpoint/2010/main" saveSubsetFonts="1" autoCompressPictures="0">
   <p:sldMasterIdLst>
-    <p:sldMasterId id="2147483648" r:id="rId1"/>
+    <p:sldMasterId id="2147483650" r:id="rId3"/>
   </p:sldMasterIdLst>
+  <p:notesMasterIdLst>
+    <p:notesMasterId r:id="rId5"/>
+  </p:notesMasterIdLst>
   <p:sldIdLst>
-    <p:sldId id="256" r:id="rId2"/>
-    <p:sldId id="257" r:id="rId3"/>
-    <p:sldId id="258" r:id="rId4"/>
-    <p:sldId id="259" r:id="rId5"/>
-    <p:sldId id="260" r:id="rId6"/>
-    <p:sldId id="261" r:id="rId7"/>
-    <p:sldId id="262" r:id="rId8"/>
-    <p:sldId id="263" r:id="rId9"/>
-    <p:sldId id="264" r:id="rId10"/>
-    <p:sldId id="265" r:id="rId11"/>
+    <p:sldId id="256" r:id="rId7"/>
+    <p:sldId id="257" r:id="rId8"/>
+    <p:sldId id="258" r:id="rId10"/>
+    <p:sldId id="259" r:id="rId12"/>
+    <p:sldId id="260" r:id="rId14"/>
+    <p:sldId id="261" r:id="rId16"/>
+    <p:sldId id="262" r:id="rId18"/>
+    <p:sldId id="263" r:id="rId20"/>
+    <p:sldId id="264" r:id="rId22"/>
+    <p:sldId id="265" r:id="rId24"/>
   </p:sldIdLst>
-  <p:notesMasterIdLst>
-    <p:notesMasterId r:id="rId12"/>
-  </p:notesMasterIdLst>
+  <p:notesMasterIdLst/>
   <p:sldSz cx="12192000" cy="6858000"/>
   <p:notesSz cx="6858000" cy="12192000"/>
   <p:defaultTextStyle>
@@ -2438,7 +2439,7 @@
 </file>
 
 <file path=ppt/slides/slide1.xml><?xml version="1.0" encoding="utf-8"?>
-<p:sld xmlns:a="http://schemas.openxmlformats.org/drawingml/2006/main" xmlns:r="http://schemas.openxmlformats.org/officeDocument/2006/relationships" xmlns:p="http://schemas.openxmlformats.org/presentationml/2006/main">
+<p:sld xmlns:a="http://schemas.openxmlformats.org/drawingml/2006/main" xmlns:r="http://schemas.openxmlformats.org/officeDocument/2006/relationships" xmlns:p="http://schemas.openxmlformats.org/presentationml/2006/main" xmlns:p14="http://schemas.microsoft.com/office/powerpoint/2010/main">
   <p:cSld name="Slide 1">
     <p:bg>
       <p:bgPr>
@@ -2469,8 +2470,8 @@
         </p:nvSpPr>
         <p:spPr>
           <a:xfrm>
-            <a:off x="548640" y="566928"/>
-            <a:ext cx="118872" cy="118872"/>
+            <a:off x="548640" y="567055"/>
+            <a:ext cx="118745" cy="118745"/>
           </a:xfrm>
           <a:prstGeom prst="rect">
             <a:avLst/>
@@ -2698,7 +2699,7 @@
         </p:nvSpPr>
         <p:spPr>
           <a:xfrm>
-            <a:off x="713232" y="4892040"/>
+            <a:off x="713105" y="4892040"/>
             <a:ext cx="1463040" cy="274320"/>
           </a:xfrm>
           <a:prstGeom prst="rect">
@@ -2737,7 +2738,7 @@
         </p:nvSpPr>
         <p:spPr>
           <a:xfrm>
-            <a:off x="713232" y="5166360"/>
+            <a:off x="713105" y="5166360"/>
             <a:ext cx="1508760" cy="411480"/>
           </a:xfrm>
           <a:prstGeom prst="rect">
@@ -2801,7 +2802,7 @@
         </p:nvSpPr>
         <p:spPr>
           <a:xfrm>
-            <a:off x="2587752" y="4892040"/>
+            <a:off x="2587625" y="4892040"/>
             <a:ext cx="1463040" cy="274320"/>
           </a:xfrm>
           <a:prstGeom prst="rect">
@@ -2840,7 +2841,7 @@
         </p:nvSpPr>
         <p:spPr>
           <a:xfrm>
-            <a:off x="2587752" y="5166360"/>
+            <a:off x="2587625" y="5166360"/>
             <a:ext cx="1508760" cy="411480"/>
           </a:xfrm>
           <a:prstGeom prst="rect">
@@ -2904,7 +2905,7 @@
         </p:nvSpPr>
         <p:spPr>
           <a:xfrm>
-            <a:off x="4462272" y="4892040"/>
+            <a:off x="4462145" y="4892040"/>
             <a:ext cx="1463040" cy="274320"/>
           </a:xfrm>
           <a:prstGeom prst="rect">
@@ -2943,7 +2944,7 @@
         </p:nvSpPr>
         <p:spPr>
           <a:xfrm>
-            <a:off x="4462272" y="5166360"/>
+            <a:off x="4462145" y="5166360"/>
             <a:ext cx="1508760" cy="411480"/>
           </a:xfrm>
           <a:prstGeom prst="rect">
@@ -2983,33 +2984,65 @@
         <p:spPr>
           <a:xfrm>
             <a:off x="548640" y="6035040"/>
-            <a:ext cx="5669280" cy="320040"/>
-          </a:xfrm>
-          <a:prstGeom prst="rect">
-            <a:avLst/>
-          </a:prstGeom>
-          <a:noFill/>
-          <a:ln/>
-        </p:spPr>
-        <p:txBody>
-          <a:bodyPr wrap="square" lIns="0" tIns="0" rIns="0" bIns="0" rtlCol="0" anchor="ctr"/>
-          <a:lstStyle/>
-          <a:p>
-            <a:pPr indent="0" marL="0">
-              <a:buNone/>
-            </a:pPr>
-            <a:r>
-              <a:rPr lang="ko-KR" altLang="en-US" sz="1200" dirty="0">
+            <a:ext cx="5669915" cy="320675"/>
+          </a:xfrm>
+          <a:prstGeom prst="rect">
+            <a:avLst/>
+          </a:prstGeom>
+          <a:noFill/>
+          <a:ln/>
+        </p:spPr>
+        <p:txBody>
+          <a:bodyPr wrap="square" lIns="0" tIns="0" rIns="0" bIns="0" numCol="1" vert="horz" anchor="ctr">
+            <a:noAutofit/>
+          </a:bodyPr>
+          <a:lstStyle/>
+          <a:p>
+            <a:pPr marL="0" indent="0">
+              <a:buFontTx/>
+              <a:buNone/>
+            </a:pPr>
+            <a:r>
+              <a:rPr lang="ko-KR" altLang="en-US" sz="1600" b="1">
                 <a:solidFill>
                   <a:srgbClr val="94A3B8"/>
                 </a:solidFill>
-                <a:latin typeface="Malgun Gothic" pitchFamily="34" charset="0"/>
-                <a:ea typeface="Malgun Gothic" pitchFamily="34" charset="-122"/>
-                <a:cs typeface="Malgun Gothic" pitchFamily="34" charset="-120"/>
-              </a:rPr>
-              <a:t>송승호(팀장)  ·  이동혁  ·  조은수  ·  김지훈</a:t>
-            </a:r>
-            <a:endParaRPr lang="ko-KR" sz="1200" dirty="0"/>
+                <a:latin typeface="Malgun Gothic" charset="0"/>
+                <a:ea typeface="Malgun Gothic" charset="0"/>
+                <a:cs typeface="Malgun Gothic" charset="0"/>
+              </a:rPr>
+              <a:t>발표자 </a:t>
+            </a:r>
+            <a:r>
+              <a:rPr lang="ko-KR" altLang="en-US" sz="1600" b="1">
+                <a:solidFill>
+                  <a:srgbClr val="94A3B8"/>
+                </a:solidFill>
+                <a:latin typeface="Malgun Gothic" charset="0"/>
+                <a:ea typeface="Malgun Gothic" charset="0"/>
+                <a:cs typeface="Malgun Gothic" charset="0"/>
+              </a:rPr>
+              <a:t>: </a:t>
+            </a:r>
+            <a:r>
+              <a:rPr lang="ko-KR" altLang="en-US" sz="1600" b="1">
+                <a:solidFill>
+                  <a:srgbClr val="94A3B8"/>
+                </a:solidFill>
+                <a:latin typeface="Malgun Gothic" charset="0"/>
+                <a:ea typeface="Malgun Gothic" charset="0"/>
+                <a:cs typeface="Malgun Gothic" charset="0"/>
+              </a:rPr>
+              <a:t>김지훈</a:t>
+            </a:r>
+            <a:endParaRPr lang="ko-KR" altLang="en-US" sz="1600" b="1">
+              <a:solidFill>
+                <a:srgbClr val="94A3B8"/>
+              </a:solidFill>
+              <a:latin typeface="Malgun Gothic" charset="0"/>
+              <a:ea typeface="Malgun Gothic" charset="0"/>
+              <a:cs typeface="Malgun Gothic" charset="0"/>
+            </a:endParaRPr>
           </a:p>
         </p:txBody>
       </p:sp>
@@ -3021,8 +3054,8 @@
         </p:nvSpPr>
         <p:spPr>
           <a:xfrm>
-            <a:off x="6373368" y="1527048"/>
-            <a:ext cx="5342839" cy="3069355"/>
+            <a:off x="6373495" y="1527175"/>
+            <a:ext cx="5342890" cy="3069590"/>
           </a:xfrm>
           <a:prstGeom prst="rect">
             <a:avLst/>
@@ -3040,7 +3073,7 @@
       </p:sp>
       <p:pic>
         <p:nvPicPr>
-          <p:cNvPr id="18" name="Image 0" descr="C:/SafeSign_PhysicalAI/services/portal/frontend/media/station-judging-poster.jpg">    </p:cNvPr>
+          <p:cNvPr id="18" name="Image 0">    </p:cNvPr>
           <p:cNvPicPr>
             <a:picLocks noChangeAspect="1"/>
           </p:cNvPicPr>
@@ -3055,7 +3088,7 @@
         <p:spPr>
           <a:xfrm>
             <a:off x="6446520" y="1600200"/>
-            <a:ext cx="5196535" cy="2923051"/>
+            <a:ext cx="5196840" cy="2922905"/>
           </a:xfrm>
           <a:prstGeom prst="rect">
             <a:avLst/>
@@ -3070,8 +3103,8 @@
         </p:nvSpPr>
         <p:spPr>
           <a:xfrm>
-            <a:off x="6446520" y="4706131"/>
-            <a:ext cx="5196535" cy="274320"/>
+            <a:off x="6446520" y="4705985"/>
+            <a:ext cx="5196840" cy="274320"/>
           </a:xfrm>
           <a:prstGeom prst="rect">
             <a:avLst/>
@@ -3106,6 +3139,21 @@
   <p:clrMapOvr>
     <a:masterClrMapping/>
   </p:clrMapOvr>
+  <mc:AlternateContent xmlns:mc="http://schemas.openxmlformats.org/markup-compatibility/2006">
+    <mc:Choice xmlns:p14="http://schemas.microsoft.com/office/powerpoint/2010/main" Requires="p14">
+      <p:transition spd="slow" p14:dur="2000"/>
+    </mc:Choice>
+    <mc:Fallback>
+      <p:transition spd="slow"/>
+    </mc:Fallback>
+  </mc:AlternateContent>
+  <p:timing>
+    <p:tnLst>
+      <p:par>
+        <p:cTn id="1" dur="indefinite" restart="never" nodeType="tmRoot"/>
+      </p:par>
+    </p:tnLst>
+  </p:timing>
 </p:sld>
 </file>
 
@@ -12405,7 +12453,7 @@
 </p:sld>
 </file>
 
-<file path=ppt/theme/theme1.xml><?xml version="1.0" encoding="utf-8"?>
+<file path=ppt/theme/theme2.xml><?xml version="1.0" encoding="utf-8"?>
 <a:theme xmlns:a="http://schemas.openxmlformats.org/drawingml/2006/main" name="Office Theme">
   <a:themeElements>
     <a:clrScheme name="Office">

</xml_diff>